<commit_message>
Integrate GitHub technical report links into presentation PPTX/PDF and master notes, add detailed limitations roadmap
</commit_message>
<xml_diff>
--- a/docs/VeriGuard_AI_SIH2026_Submission.pptx
+++ b/docs/VeriGuard_AI_SIH2026_Submission.pptx
@@ -3230,11 +3230,11 @@
           <a:p>
             <a:pPr algn="ctr">
               <a:spcAft>
-                <a:spcPts val="400"/>
+                <a:spcPts val="300"/>
               </a:spcAft>
             </a:pPr>
             <a:r>
-              <a:rPr sz="1100" b="1">
+              <a:rPr sz="1000" b="1">
                 <a:solidFill>
                   <a:srgbClr val="1E293B"/>
                 </a:solidFill>
@@ -3242,7 +3242,7 @@
               <a:t>Problem Statement ID – </a:t>
             </a:r>
             <a:r>
-              <a:rPr sz="1100" b="1">
+              <a:rPr sz="1000" b="1">
                 <a:solidFill>
                   <a:srgbClr val="0070C0"/>
                 </a:solidFill>
@@ -3253,11 +3253,11 @@
           <a:p>
             <a:pPr>
               <a:spcAft>
-                <a:spcPts val="400"/>
+                <a:spcPts val="300"/>
               </a:spcAft>
             </a:pPr>
             <a:r>
-              <a:rPr sz="1100" b="1">
+              <a:rPr sz="1000" b="1">
                 <a:solidFill>
                   <a:srgbClr val="1E293B"/>
                 </a:solidFill>
@@ -3265,7 +3265,7 @@
               <a:t>Problem Statement Title – </a:t>
             </a:r>
             <a:r>
-              <a:rPr sz="1100" b="1">
+              <a:rPr sz="1000" b="1">
                 <a:solidFill>
                   <a:srgbClr val="1E293B"/>
                 </a:solidFill>
@@ -3276,11 +3276,11 @@
           <a:p>
             <a:pPr>
               <a:spcAft>
-                <a:spcPts val="400"/>
+                <a:spcPts val="300"/>
               </a:spcAft>
             </a:pPr>
             <a:r>
-              <a:rPr sz="1100" b="1">
+              <a:rPr sz="1000" b="1">
                 <a:solidFill>
                   <a:srgbClr val="1E293B"/>
                 </a:solidFill>
@@ -3288,7 +3288,7 @@
               <a:t>Theme – </a:t>
             </a:r>
             <a:r>
-              <a:rPr sz="1100" b="1">
+              <a:rPr sz="1000" b="1">
                 <a:solidFill>
                   <a:srgbClr val="5B21B6"/>
                 </a:solidFill>
@@ -3299,11 +3299,11 @@
           <a:p>
             <a:pPr>
               <a:spcAft>
-                <a:spcPts val="400"/>
+                <a:spcPts val="300"/>
               </a:spcAft>
             </a:pPr>
             <a:r>
-              <a:rPr sz="1100" b="1">
+              <a:rPr sz="1000" b="1">
                 <a:solidFill>
                   <a:srgbClr val="1E293B"/>
                 </a:solidFill>
@@ -3311,7 +3311,7 @@
               <a:t>PS Category – </a:t>
             </a:r>
             <a:r>
-              <a:rPr sz="1100" b="1">
+              <a:rPr sz="1000" b="1">
                 <a:solidFill>
                   <a:srgbClr val="1E40AF"/>
                 </a:solidFill>
@@ -3322,11 +3322,11 @@
           <a:p>
             <a:pPr>
               <a:spcAft>
-                <a:spcPts val="400"/>
+                <a:spcPts val="300"/>
               </a:spcAft>
             </a:pPr>
             <a:r>
-              <a:rPr sz="1100" b="1">
+              <a:rPr sz="1000" b="1">
                 <a:solidFill>
                   <a:srgbClr val="1E293B"/>
                 </a:solidFill>
@@ -3334,7 +3334,7 @@
               <a:t>Team ID – </a:t>
             </a:r>
             <a:r>
-              <a:rPr sz="1100" b="1">
+              <a:rPr sz="1000" b="1">
                 <a:solidFill>
                   <a:srgbClr val="1E293B"/>
                 </a:solidFill>
@@ -3345,11 +3345,11 @@
           <a:p>
             <a:pPr>
               <a:spcAft>
-                <a:spcPts val="400"/>
+                <a:spcPts val="300"/>
               </a:spcAft>
             </a:pPr>
             <a:r>
-              <a:rPr sz="1100" b="1">
+              <a:rPr sz="1000" b="1">
                 <a:solidFill>
                   <a:srgbClr val="1E293B"/>
                 </a:solidFill>
@@ -3357,12 +3357,36 @@
               <a:t>Team Name (Registered) – </a:t>
             </a:r>
             <a:r>
-              <a:rPr sz="1100" b="1">
+              <a:rPr sz="1000" b="1">
                 <a:solidFill>
                   <a:srgbClr val="5B21B6"/>
                 </a:solidFill>
               </a:rPr>
               <a:t>Abstract_Minds</a:t>
+            </a:r>
+          </a:p>
+          <a:p>
+            <a:pPr>
+              <a:spcAft>
+                <a:spcPts val="300"/>
+              </a:spcAft>
+            </a:pPr>
+            <a:r>
+              <a:rPr sz="1000" b="1">
+                <a:solidFill>
+                  <a:srgbClr val="1E293B"/>
+                </a:solidFill>
+              </a:rPr>
+              <a:t>Technical Report – </a:t>
+            </a:r>
+            <a:r>
+              <a:rPr sz="950" b="1" u="sng">
+                <a:solidFill>
+                  <a:srgbClr val="0070C0"/>
+                </a:solidFill>
+                <a:hlinkClick r:id="rId3"/>
+              </a:rPr>
+              <a:t>https://github.com/arnaashah06/veriguard-ai/blob/main/technical_report.md</a:t>
             </a:r>
           </a:p>
         </p:txBody>
@@ -3973,7 +3997,7 @@
           <p:nvPr/>
         </p:nvPicPr>
         <p:blipFill>
-          <a:blip r:embed="rId3"/>
+          <a:blip r:embed="rId4"/>
           <a:stretch>
             <a:fillRect/>
           </a:stretch>
@@ -8492,10 +8516,11 @@
               <a:t>• Technical Report (Sec 9 Mitigations): </a:t>
             </a:r>
             <a:r>
-              <a:rPr b="0">
-                <a:solidFill>
-                  <a:srgbClr val="1E293B"/>
-                </a:solidFill>
+              <a:rPr b="0" u="sng">
+                <a:solidFill>
+                  <a:srgbClr val="0070C0"/>
+                </a:solidFill>
+                <a:hlinkClick r:id="rId3"/>
               </a:rPr>
               <a:t>https://github.com/arnaashah06/veriguard-ai/blob/main/technical_report.md</a:t>
             </a:r>

</xml_diff>